<commit_message>
Name the guide on the cover, drop the QR codes, export the PDF
The cover now labels A Aswanth Raj as presenter and Dr. Ranjithkumar S
as guide; the cover and closing slides show the GitHub link as text.
MatrixLang-Presentation.pdf is the LibreOffice export of the deck.

Co-Authored-By: Claude Opus 5.5 <noreply@anthropic.com>
Claude-Session: https://claude.ai/code/session_01BWvZFZvTouoh7gNEs1yyHK
</commit_message>
<xml_diff>
--- a/paper/presentation-updated/MatrixLang-Presentation.pptx
+++ b/paper/presentation-updated/MatrixLang-Presentation.pptx
@@ -117,28 +117,28 @@
   <p:extLst>
     <p:ext uri="{521415D9-36F7-43E2-AB2F-B90AF26B5E84}">
       <p14:sectionLst xmlns:p14="http://schemas.microsoft.com/office/powerpoint/2010/main">
-        <p14:section name="Introduction" id="{481530e2-7647-1d4e-676a-6aa417adf2aa}">
+        <p14:section name="Introduction" id="{37fa478e-bb22-c4ce-8c31-93db04b597b3}">
           <p14:sldIdLst>
             <p14:sldId id="256"/>
             <p14:sldId id="257"/>
             <p14:sldId id="258"/>
           </p14:sldIdLst>
         </p14:section>
-        <p14:section name="Approach" id="{fa01999a-de2d-1996-8046-c9cd4e184c43}">
+        <p14:section name="Approach" id="{5929fb71-f7d9-6770-232a-bbf6b53d28b6}">
           <p14:sldIdLst>
             <p14:sldId id="259"/>
             <p14:sldId id="260"/>
             <p14:sldId id="261"/>
           </p14:sldIdLst>
         </p14:section>
-        <p14:section name="Results" id="{4a3b923a-1a1e-0a19-47e4-7aa1e6daa7b5}">
+        <p14:section name="Results" id="{f5779159-d33a-5030-3704-9cdf6d8cda4f}">
           <p14:sldIdLst>
             <p14:sldId id="262"/>
             <p14:sldId id="263"/>
             <p14:sldId id="264"/>
           </p14:sldIdLst>
         </p14:section>
-        <p14:section name="Conclusion" id="{69900a46-4b25-59b3-ccbf-9611971af20e}">
+        <p14:section name="Conclusion" id="{66b0de98-08bc-185b-7367-212be0a16e4c}">
           <p14:sldIdLst>
             <p14:sldId id="265"/>
             <p14:sldId id="266"/>
@@ -2373,8 +2373,8 @@
         </p:nvSpPr>
         <p:spPr>
           <a:xfrm>
-            <a:off x="731520" y="1463040"/>
-            <a:ext cx="7863840" cy="2194560"/>
+            <a:off x="731520" y="1371600"/>
+            <a:ext cx="10698480" cy="2286000"/>
           </a:xfrm>
           <a:prstGeom prst="rect">
             <a:avLst/>
@@ -2950,7 +2950,7 @@
         </p:nvSpPr>
         <p:spPr>
           <a:xfrm>
-            <a:off x="731520" y="1051560"/>
+            <a:off x="731520" y="2423160"/>
             <a:ext cx="7315200" cy="365760"/>
           </a:xfrm>
           <a:prstGeom prst="rect">
@@ -2988,8 +2988,8 @@
         </p:nvSpPr>
         <p:spPr>
           <a:xfrm>
-            <a:off x="731520" y="1463040"/>
-            <a:ext cx="7863840" cy="2194560"/>
+            <a:off x="731520" y="1371600"/>
+            <a:ext cx="10698480" cy="2286000"/>
           </a:xfrm>
           <a:prstGeom prst="rect">
             <a:avLst/>
@@ -3060,8 +3060,8 @@
         </p:nvSpPr>
         <p:spPr>
           <a:xfrm>
-            <a:off x="731520" y="4892040"/>
-            <a:ext cx="7315200" cy="731520"/>
+            <a:off x="731520" y="4526280"/>
+            <a:ext cx="3291840" cy="274320"/>
           </a:xfrm>
           <a:prstGeom prst="rect">
             <a:avLst/>
@@ -3074,72 +3074,167 @@
           <a:lstStyle/>
           <a:p>
             <a:pPr indent="0" marL="0">
-              <a:spcAft>
-                <a:spcPts val="400"/>
-              </a:spcAft>
-              <a:buNone/>
-            </a:pPr>
-            <a:r>
-              <a:rPr lang="en-US" sz="1600" b="1" dirty="0">
+              <a:buNone/>
+            </a:pPr>
+            <a:r>
+              <a:rPr lang="en-US" sz="1100" b="1" spc="400" kern="0" dirty="0">
+                <a:solidFill>
+                  <a:schemeClr val="accent1"/>
+                </a:solidFill>
+              </a:rPr>
+              <a:t>PRESENTED BY</a:t>
+            </a:r>
+            <a:endParaRPr lang="en-US" sz="1100" dirty="0"/>
+          </a:p>
+        </p:txBody>
+      </p:sp>
+      <p:sp>
+        <p:nvSpPr>
+          <p:cNvPr id="6" name="Text 4"/>
+          <p:cNvSpPr txBox="1"/>
+          <p:nvPr/>
+        </p:nvSpPr>
+        <p:spPr>
+          <a:xfrm>
+            <a:off x="731520" y="4800600"/>
+            <a:ext cx="3291840" cy="411480"/>
+          </a:xfrm>
+          <a:prstGeom prst="rect">
+            <a:avLst/>
+          </a:prstGeom>
+          <a:noFill/>
+          <a:ln/>
+        </p:spPr>
+        <p:txBody>
+          <a:bodyPr wrap="square" lIns="0" tIns="0" rIns="0" bIns="0" rtlCol="0" anchor="t"/>
+          <a:lstStyle/>
+          <a:p>
+            <a:pPr indent="0" marL="0">
+              <a:buNone/>
+            </a:pPr>
+            <a:r>
+              <a:rPr lang="en-US" sz="2000" b="1" dirty="0">
                 <a:solidFill>
                   <a:schemeClr val="bg1"/>
                 </a:solidFill>
               </a:rPr>
-              <a:t>A Aswanth Raj   ·   Dr. Ranjithkumar S</a:t>
-            </a:r>
-            <a:endParaRPr lang="en-US" sz="1600" dirty="0"/>
-          </a:p>
+              <a:t>A Aswanth Raj</a:t>
+            </a:r>
+            <a:endParaRPr lang="en-US" sz="2000" dirty="0"/>
+          </a:p>
+        </p:txBody>
+      </p:sp>
+      <p:sp>
+        <p:nvSpPr>
+          <p:cNvPr id="7" name="Text 5"/>
+          <p:cNvSpPr txBox="1"/>
+          <p:nvPr/>
+        </p:nvSpPr>
+        <p:spPr>
+          <a:xfrm>
+            <a:off x="4206240" y="4526280"/>
+            <a:ext cx="3291840" cy="274320"/>
+          </a:xfrm>
+          <a:prstGeom prst="rect">
+            <a:avLst/>
+          </a:prstGeom>
+          <a:noFill/>
+          <a:ln/>
+        </p:spPr>
+        <p:txBody>
+          <a:bodyPr wrap="square" lIns="0" tIns="0" rIns="0" bIns="0" rtlCol="0" anchor="t"/>
+          <a:lstStyle/>
           <a:p>
             <a:pPr indent="0" marL="0">
-              <a:spcAft>
-                <a:spcPts val="400"/>
-              </a:spcAft>
-              <a:buNone/>
-            </a:pPr>
-            <a:r>
-              <a:rPr lang="en-US" sz="1600" dirty="0">
+              <a:buNone/>
+            </a:pPr>
+            <a:r>
+              <a:rPr lang="en-US" sz="1100" b="1" spc="400" kern="0" dirty="0">
+                <a:solidFill>
+                  <a:schemeClr val="accent1"/>
+                </a:solidFill>
+              </a:rPr>
+              <a:t>GUIDE</a:t>
+            </a:r>
+            <a:endParaRPr lang="en-US" sz="1100" dirty="0"/>
+          </a:p>
+        </p:txBody>
+      </p:sp>
+      <p:sp>
+        <p:nvSpPr>
+          <p:cNvPr id="8" name="Text 6"/>
+          <p:cNvSpPr txBox="1"/>
+          <p:nvPr/>
+        </p:nvSpPr>
+        <p:spPr>
+          <a:xfrm>
+            <a:off x="4206240" y="4800600"/>
+            <a:ext cx="3291840" cy="411480"/>
+          </a:xfrm>
+          <a:prstGeom prst="rect">
+            <a:avLst/>
+          </a:prstGeom>
+          <a:noFill/>
+          <a:ln/>
+        </p:spPr>
+        <p:txBody>
+          <a:bodyPr wrap="square" lIns="0" tIns="0" rIns="0" bIns="0" rtlCol="0" anchor="t"/>
+          <a:lstStyle/>
+          <a:p>
+            <a:pPr indent="0" marL="0">
+              <a:buNone/>
+            </a:pPr>
+            <a:r>
+              <a:rPr lang="en-US" sz="2000" b="1" dirty="0">
+                <a:solidFill>
+                  <a:schemeClr val="bg1"/>
+                </a:solidFill>
+              </a:rPr>
+              <a:t>Dr. Ranjithkumar S</a:t>
+            </a:r>
+            <a:endParaRPr lang="en-US" sz="2000" dirty="0"/>
+          </a:p>
+        </p:txBody>
+      </p:sp>
+      <p:sp>
+        <p:nvSpPr>
+          <p:cNvPr id="9" name="Text 7"/>
+          <p:cNvSpPr txBox="1"/>
+          <p:nvPr/>
+        </p:nvSpPr>
+        <p:spPr>
+          <a:xfrm>
+            <a:off x="731520" y="5303520"/>
+            <a:ext cx="7315200" cy="320040"/>
+          </a:xfrm>
+          <a:prstGeom prst="rect">
+            <a:avLst/>
+          </a:prstGeom>
+          <a:noFill/>
+          <a:ln/>
+        </p:spPr>
+        <p:txBody>
+          <a:bodyPr wrap="square" lIns="0" tIns="0" rIns="0" bIns="0" rtlCol="0" anchor="t"/>
+          <a:lstStyle/>
+          <a:p>
+            <a:pPr indent="0" marL="0">
+              <a:buNone/>
+            </a:pPr>
+            <a:r>
+              <a:rPr lang="en-US" sz="1500" dirty="0">
                 <a:solidFill>
                   <a:schemeClr val="accent4"/>
                 </a:solidFill>
               </a:rPr>
               <a:t>School of Computer Science and Engineering, VIT Vellore</a:t>
             </a:r>
-            <a:endParaRPr lang="en-US" sz="1600" dirty="0"/>
-          </a:p>
-        </p:txBody>
-      </p:sp>
-      <p:sp>
-        <p:nvSpPr>
-          <p:cNvPr id="6" name="repo card"/>
-          <p:cNvSpPr/>
-          <p:nvPr/>
-        </p:nvSpPr>
-        <p:spPr>
-          <a:xfrm>
-            <a:off x="8869680" y="1554480"/>
-            <a:ext cx="2606040" cy="3429000"/>
-          </a:xfrm>
-          <a:prstGeom prst="roundRect">
-            <a:avLst>
-              <a:gd name="adj" fmla="val 3509"/>
-            </a:avLst>
-          </a:prstGeom>
-          <a:solidFill>
-            <a:schemeClr val="tx1"/>
-          </a:solidFill>
-          <a:ln w="15875">
-            <a:solidFill>
-              <a:schemeClr val="accent1"/>
-            </a:solidFill>
-            <a:prstDash val="solid"/>
-          </a:ln>
-        </p:spPr>
+            <a:endParaRPr lang="en-US" sz="1500" dirty="0"/>
+          </a:p>
+        </p:txBody>
       </p:sp>
       <p:pic>
         <p:nvPicPr>
-          <p:cNvPr id="7" name="Image 0" descr="QR code linking to https://github.com/aswanth-07/matrixlang">
-            <a:hlinkClick r:id="rId2" tooltip=""/>
-          </p:cNvPr>
+          <p:cNvPr id="10" name="Image 0" descr="preencoded.png">    </p:cNvPr>
           <p:cNvPicPr>
             <a:picLocks noChangeAspect="1"/>
           </p:cNvPicPr>
@@ -3153,48 +3248,24 @@
         </p:blipFill>
         <p:spPr>
           <a:xfrm>
-            <a:off x="9235440" y="1874520"/>
-            <a:ext cx="1874520" cy="1874520"/>
+            <a:off x="731520" y="5897880"/>
+            <a:ext cx="310896" cy="310896"/>
           </a:xfrm>
           <a:prstGeom prst="rect">
             <a:avLst/>
           </a:prstGeom>
         </p:spPr>
       </p:pic>
-      <p:pic>
-        <p:nvPicPr>
-          <p:cNvPr id="8" name="Image 1" descr="preencoded.png">    </p:cNvPr>
-          <p:cNvPicPr>
-            <a:picLocks noChangeAspect="1"/>
-          </p:cNvPicPr>
-          <p:nvPr/>
-        </p:nvPicPr>
-        <p:blipFill>
-          <a:blip r:embed="rId3"/>
-          <a:stretch>
-            <a:fillRect/>
-          </a:stretch>
-        </p:blipFill>
-        <p:spPr>
-          <a:xfrm>
-            <a:off x="9235440" y="3977640"/>
-            <a:ext cx="274320" cy="274320"/>
-          </a:xfrm>
-          <a:prstGeom prst="rect">
-            <a:avLst/>
-          </a:prstGeom>
-        </p:spPr>
-      </p:pic>
-      <p:sp>
-        <p:nvSpPr>
-          <p:cNvPr id="9" name="Text 5"/>
-          <p:cNvSpPr txBox="1"/>
-          <p:nvPr/>
-        </p:nvSpPr>
-        <p:spPr>
-          <a:xfrm>
-            <a:off x="9601200" y="3977640"/>
-            <a:ext cx="1737360" cy="274320"/>
+      <p:sp>
+        <p:nvSpPr>
+          <p:cNvPr id="11" name="Text 8"/>
+          <p:cNvSpPr txBox="1"/>
+          <p:nvPr/>
+        </p:nvSpPr>
+        <p:spPr>
+          <a:xfrm>
+            <a:off x="1188720" y="5897880"/>
+            <a:ext cx="5486400" cy="310896"/>
           </a:xfrm>
           <a:prstGeom prst="rect">
             <a:avLst/>
@@ -3210,47 +3281,11 @@
               <a:buNone/>
             </a:pPr>
             <a:r>
-              <a:rPr lang="en-US" sz="1200" b="1" dirty="0">
-                <a:solidFill>
-                  <a:schemeClr val="accent1"/>
-                </a:solidFill>
-              </a:rPr>
-              <a:t>Code · data · paper</a:t>
-            </a:r>
-            <a:endParaRPr lang="en-US" sz="1200" dirty="0"/>
-          </a:p>
-        </p:txBody>
-      </p:sp>
-      <p:sp>
-        <p:nvSpPr>
-          <p:cNvPr id="10" name="Text 6"/>
-          <p:cNvSpPr txBox="1"/>
-          <p:nvPr/>
-        </p:nvSpPr>
-        <p:spPr>
-          <a:xfrm>
-            <a:off x="8961120" y="4389120"/>
-            <a:ext cx="2423160" cy="274320"/>
-          </a:xfrm>
-          <a:prstGeom prst="rect">
-            <a:avLst/>
-          </a:prstGeom>
-          <a:noFill/>
-          <a:ln/>
-        </p:spPr>
-        <p:txBody>
-          <a:bodyPr wrap="square" lIns="0" tIns="0" rIns="0" bIns="0" rtlCol="0" anchor="t"/>
-          <a:lstStyle/>
-          <a:p>
-            <a:pPr algn="ctr" indent="0" marL="0">
-              <a:buNone/>
-            </a:pPr>
-            <a:r>
-              <a:rPr lang="en-US" sz="1050" u="sng" dirty="0">
+              <a:rPr lang="en-US" sz="1600" u="sng" dirty="0">
                 <a:solidFill>
                   <a:schemeClr val="bg2"/>
                 </a:solidFill>
-                <a:hlinkClick r:id="rId4" invalidUrl="" action="" tgtFrame="" tooltip="" history="1" highlightClick="0" endSnd="0">
+                <a:hlinkClick r:id="rId2" invalidUrl="" action="" tgtFrame="" tooltip="" history="1" highlightClick="0" endSnd="0">
                   <a:extLst>
                     <a:ext uri="{A12FA001-AC4F-418D-AE19-62706E023703}">
                       <ahyp:hlinkClr xmlns:ahyp="http://schemas.microsoft.com/office/drawing/2018/hyperlinkcolor" val="tx"/>
@@ -3260,7 +3295,7 @@
               </a:rPr>
               <a:t>github.com/aswanth-07/matrixlang</a:t>
             </a:r>
-            <a:endParaRPr lang="en-US" sz="1050" dirty="0"/>
+            <a:endParaRPr lang="en-US" sz="1600" dirty="0"/>
           </a:p>
         </p:txBody>
       </p:sp>
@@ -3947,7 +3982,7 @@
         </p:nvSpPr>
         <p:spPr>
           <a:xfrm>
-            <a:off x="731520" y="1051560"/>
+            <a:off x="731520" y="2423160"/>
             <a:ext cx="7315200" cy="365760"/>
           </a:xfrm>
           <a:prstGeom prst="rect">
@@ -3985,8 +4020,8 @@
         </p:nvSpPr>
         <p:spPr>
           <a:xfrm>
-            <a:off x="731520" y="1463040"/>
-            <a:ext cx="7863840" cy="2194560"/>
+            <a:off x="731520" y="1371600"/>
+            <a:ext cx="10698480" cy="2286000"/>
           </a:xfrm>
           <a:prstGeom prst="rect">
             <a:avLst/>
@@ -4085,38 +4120,9 @@
           </a:p>
         </p:txBody>
       </p:sp>
-      <p:sp>
-        <p:nvSpPr>
-          <p:cNvPr id="6" name="repo card"/>
-          <p:cNvSpPr/>
-          <p:nvPr/>
-        </p:nvSpPr>
-        <p:spPr>
-          <a:xfrm>
-            <a:off x="8869680" y="1554480"/>
-            <a:ext cx="2606040" cy="3429000"/>
-          </a:xfrm>
-          <a:prstGeom prst="roundRect">
-            <a:avLst>
-              <a:gd name="adj" fmla="val 3509"/>
-            </a:avLst>
-          </a:prstGeom>
-          <a:solidFill>
-            <a:schemeClr val="tx1"/>
-          </a:solidFill>
-          <a:ln w="15875">
-            <a:solidFill>
-              <a:schemeClr val="accent1"/>
-            </a:solidFill>
-            <a:prstDash val="solid"/>
-          </a:ln>
-        </p:spPr>
-      </p:sp>
       <p:pic>
         <p:nvPicPr>
-          <p:cNvPr id="7" name="Image 0" descr="QR code linking to https://github.com/aswanth-07/matrixlang">
-            <a:hlinkClick r:id="rId2" tooltip=""/>
-          </p:cNvPr>
+          <p:cNvPr id="6" name="Image 0" descr="preencoded.png">    </p:cNvPr>
           <p:cNvPicPr>
             <a:picLocks noChangeAspect="1"/>
           </p:cNvPicPr>
@@ -4130,48 +4136,24 @@
         </p:blipFill>
         <p:spPr>
           <a:xfrm>
-            <a:off x="9235440" y="1874520"/>
-            <a:ext cx="1874520" cy="1874520"/>
+            <a:off x="731520" y="5897880"/>
+            <a:ext cx="310896" cy="310896"/>
           </a:xfrm>
           <a:prstGeom prst="rect">
             <a:avLst/>
           </a:prstGeom>
         </p:spPr>
       </p:pic>
-      <p:pic>
-        <p:nvPicPr>
-          <p:cNvPr id="8" name="Image 1" descr="preencoded.png">    </p:cNvPr>
-          <p:cNvPicPr>
-            <a:picLocks noChangeAspect="1"/>
-          </p:cNvPicPr>
-          <p:nvPr/>
-        </p:nvPicPr>
-        <p:blipFill>
-          <a:blip r:embed="rId3"/>
-          <a:stretch>
-            <a:fillRect/>
-          </a:stretch>
-        </p:blipFill>
-        <p:spPr>
-          <a:xfrm>
-            <a:off x="9235440" y="3977640"/>
-            <a:ext cx="274320" cy="274320"/>
-          </a:xfrm>
-          <a:prstGeom prst="rect">
-            <a:avLst/>
-          </a:prstGeom>
-        </p:spPr>
-      </p:pic>
-      <p:sp>
-        <p:nvSpPr>
-          <p:cNvPr id="9" name="Text 5"/>
-          <p:cNvSpPr txBox="1"/>
-          <p:nvPr/>
-        </p:nvSpPr>
-        <p:spPr>
-          <a:xfrm>
-            <a:off x="9601200" y="3977640"/>
-            <a:ext cx="1737360" cy="274320"/>
+      <p:sp>
+        <p:nvSpPr>
+          <p:cNvPr id="7" name="Text 4"/>
+          <p:cNvSpPr txBox="1"/>
+          <p:nvPr/>
+        </p:nvSpPr>
+        <p:spPr>
+          <a:xfrm>
+            <a:off x="1188720" y="5897880"/>
+            <a:ext cx="5486400" cy="310896"/>
           </a:xfrm>
           <a:prstGeom prst="rect">
             <a:avLst/>
@@ -4187,47 +4169,11 @@
               <a:buNone/>
             </a:pPr>
             <a:r>
-              <a:rPr lang="en-US" sz="1200" b="1" dirty="0">
-                <a:solidFill>
-                  <a:schemeClr val="accent1"/>
-                </a:solidFill>
-              </a:rPr>
-              <a:t>Try it yourself</a:t>
-            </a:r>
-            <a:endParaRPr lang="en-US" sz="1200" dirty="0"/>
-          </a:p>
-        </p:txBody>
-      </p:sp>
-      <p:sp>
-        <p:nvSpPr>
-          <p:cNvPr id="10" name="Text 6"/>
-          <p:cNvSpPr txBox="1"/>
-          <p:nvPr/>
-        </p:nvSpPr>
-        <p:spPr>
-          <a:xfrm>
-            <a:off x="8961120" y="4389120"/>
-            <a:ext cx="2423160" cy="274320"/>
-          </a:xfrm>
-          <a:prstGeom prst="rect">
-            <a:avLst/>
-          </a:prstGeom>
-          <a:noFill/>
-          <a:ln/>
-        </p:spPr>
-        <p:txBody>
-          <a:bodyPr wrap="square" lIns="0" tIns="0" rIns="0" bIns="0" rtlCol="0" anchor="t"/>
-          <a:lstStyle/>
-          <a:p>
-            <a:pPr algn="ctr" indent="0" marL="0">
-              <a:buNone/>
-            </a:pPr>
-            <a:r>
-              <a:rPr lang="en-US" sz="1050" u="sng" dirty="0">
+              <a:rPr lang="en-US" sz="1600" u="sng" dirty="0">
                 <a:solidFill>
                   <a:schemeClr val="bg2"/>
                 </a:solidFill>
-                <a:hlinkClick r:id="rId4" invalidUrl="" action="" tgtFrame="" tooltip="" history="1" highlightClick="0" endSnd="0">
+                <a:hlinkClick r:id="rId2" invalidUrl="" action="" tgtFrame="" tooltip="" history="1" highlightClick="0" endSnd="0">
                   <a:extLst>
                     <a:ext uri="{A12FA001-AC4F-418D-AE19-62706E023703}">
                       <ahyp:hlinkClr xmlns:ahyp="http://schemas.microsoft.com/office/drawing/2018/hyperlinkcolor" val="tx"/>
@@ -4237,46 +4183,7 @@
               </a:rPr>
               <a:t>github.com/aswanth-07/matrixlang</a:t>
             </a:r>
-            <a:endParaRPr lang="en-US" sz="1050" dirty="0"/>
-          </a:p>
-        </p:txBody>
-      </p:sp>
-      <p:sp>
-        <p:nvSpPr>
-          <p:cNvPr id="11" name="Text 7"/>
-          <p:cNvSpPr txBox="1"/>
-          <p:nvPr/>
-        </p:nvSpPr>
-        <p:spPr>
-          <a:xfrm>
-            <a:off x="8869680" y="5212080"/>
-            <a:ext cx="2606040" cy="320040"/>
-          </a:xfrm>
-          <a:prstGeom prst="rect">
-            <a:avLst/>
-          </a:prstGeom>
-          <a:noFill/>
-          <a:ln/>
-        </p:spPr>
-        <p:txBody>
-          <a:bodyPr wrap="square" lIns="0" tIns="0" rIns="0" bIns="0" rtlCol="0" anchor="t"/>
-          <a:lstStyle/>
-          <a:p>
-            <a:pPr algn="ctr" indent="0" marL="0">
-              <a:buNone/>
-            </a:pPr>
-            <a:r>
-              <a:rPr lang="en-US" sz="1300" dirty="0">
-                <a:solidFill>
-                  <a:schemeClr val="accent4"/>
-                </a:solidFill>
-                <a:latin typeface="Courier New" pitchFamily="34" charset="0"/>
-                <a:ea typeface="Courier New" pitchFamily="34" charset="-122"/>
-                <a:cs typeface="Courier New" pitchFamily="34" charset="-120"/>
-              </a:rPr>
-              <a:t>make &amp;&amp; make test</a:t>
-            </a:r>
-            <a:endParaRPr lang="en-US" sz="1300" dirty="0"/>
+            <a:endParaRPr lang="en-US" sz="1600" dirty="0"/>
           </a:p>
         </p:txBody>
       </p:sp>

</xml_diff>